<commit_message>
Add full edition: 77-slide deck and 34-page brochure with sourced charts
Adds eight chapters with native editable charts (sourced CB Insights, BLS,
OECD, Wamda, GEM, UAE government data), infographics, stage checklists,
illustrative Founder OS screens, pilot/KPI/risk pages, FAQ, glossary and
sources. Introduces photo slots that auto-fill from startup-roof/photos/.
Short 20-slide deck and 12-page brochure are kept; status note updated.

Co-Authored-By: Claude Opus 5.5 <noreply@anthropic.com>
Claude-Session: https://claude.ai/code/session_013GtFGfVbL7hjkHqYyzD8nx
</commit_message>
<xml_diff>
--- a/startup-roof/deliverables/Startup_Roof_General_Presentation.pptx
+++ b/startup-roof/deliverables/Startup_Roof_General_Presentation.pptx
@@ -20011,16 +20011,7 @@
                 </a:solidFill>
                 <a:latin typeface="Inter"/>
               </a:rPr>
-              <a:t>20</a:t>
-            </a:r>
-            <a:r>
-              <a:rPr sz="1000" b="1" i="0" spc="150">
-                <a:solidFill>
-                  <a:srgbClr val="4F8BE0"/>
-                </a:solidFill>
-                <a:latin typeface="Inter"/>
-              </a:rPr>
-              <a:t>   INVITATION TO PARTICIPATE</a:t>
+              <a:t>20   INVITATION TO PARTICIPATE</a:t>
             </a:r>
           </a:p>
         </p:txBody>

</xml_diff>